<commit_message>
Fill in the guide's designation
Dr. Mythili. T, Professor Grade 2, on the report cover and the title
slide. No placeholders remain in either deliverable.

Co-Authored-By: Claude Opus 5 <noreply@anthropic.com>
</commit_message>
<xml_diff>
--- a/report/BCSE497J_Review2_23BCB0135.pptx
+++ b/report/BCSE497J_Review2_23BCB0135.pptx
@@ -3973,6 +3973,23 @@
             </a:pPr>
             <a:r>
               <a:t>Dr. Mythili. T</a:t>
+            </a:r>
+            <a:endParaRPr sz="1800" dirty="0">
+              <a:latin typeface="Times New Roman"/>
+              <a:cs typeface="Times New Roman"/>
+            </a:endParaRPr>
+          </a:p>
+          <a:p>
+            <a:pPr>
+              <a:lnSpc>
+                <a:spcPct val="100000"/>
+              </a:lnSpc>
+              <a:spcBef>
+                <a:spcPts val="200"/>
+              </a:spcBef>
+            </a:pPr>
+            <a:r>
+              <a:t>Professor Grade 2</a:t>
             </a:r>
             <a:endParaRPr sz="1800" dirty="0">
               <a:latin typeface="Times New Roman"/>

</xml_diff>